<commit_message>
Rewrite Demand Charter content in plain, easy-to-understand language
- Replaces accounting/technical jargon (MPM, aggregation/disaggregation,
  gap assessment, IAS 1, non-GAAP, etc.) with everyday phrasing across
  the .md, .pptx, and .docx versions, while keeping the same
  structure, fields, and information.
- Adds plain-language section headings alongside the original field
  names (e.g. "What's the problem today? (Current Situation and Pain
  Points)").
- Regenerates the .pptx/.docx/preview.png from the updated generator
  scripts and re-verified all three open correctly (zip integrity +
  python-docx/python-pptx round-trip + LibreOffice render).

Co-authored-by: enikebaga <enikebaga@users.noreply.github.com>
</commit_message>
<xml_diff>
--- a/demand-charter/288-IFRS18-Demand-Charter.pptx
+++ b/demand-charter/288-IFRS18-Demand-Charter.pptx
@@ -3472,7 +3472,7 @@
                 </a:solidFill>
                 <a:latin typeface="Calibri"/>
               </a:rPr>
-              <a:t>Financial Reporting (R2R)</a:t>
+              <a:t>Financial Reporting</a:t>
             </a:r>
           </a:p>
         </p:txBody>
@@ -3753,7 +3753,7 @@
                 </a:solidFill>
                 <a:latin typeface="Calibri"/>
               </a:rPr>
-              <a:t>• IAS 1 today does not mandate P&amp;L categories/subtotals → inconsistent presentation across entities and limited peer comparability.</a:t>
+              <a:t>• No fixed structure today, so different teams present profit &amp; loss differently → hard to compare across the company or with peers.</a:t>
             </a:r>
           </a:p>
           <a:p>
@@ -3769,7 +3769,7 @@
                 </a:solidFill>
                 <a:latin typeface="Calibri"/>
               </a:rPr>
-              <a:t>• No formal governance for management-defined performance measures (MPMs) used in investor communications → audit/compliance risk.</a:t>
+              <a:t>• No clear, approved process for our "adjusted" performance numbers shown to investors → risk once we must explain how they're calculated.</a:t>
             </a:r>
           </a:p>
           <a:p>
@@ -3785,7 +3785,7 @@
                 </a:solidFill>
                 <a:latin typeface="Calibri"/>
               </a:rPr>
-              <a:t>• Chart of accounts and consolidation/reporting system not structured to auto-classify P&amp;L lines into operating / investing / financing.</a:t>
+              <a:t>• Our systems don't automatically sort P&amp;L items into the 3 new required groups: Operating, Investing, Financing.</a:t>
             </a:r>
           </a:p>
           <a:p>
@@ -3801,7 +3801,7 @@
                 </a:solidFill>
                 <a:latin typeface="Calibri"/>
               </a:rPr>
-              <a:t>• Alternative performance measures produced via manual spreadsheets with limited audit trail.</a:t>
+              <a:t>• Adjusted performance numbers are built by hand in spreadsheets — slow, error-prone, and hard for auditors to check.</a:t>
             </a:r>
           </a:p>
           <a:p>
@@ -3817,7 +3817,7 @@
                 </a:solidFill>
                 <a:latin typeface="Calibri"/>
               </a:rPr>
-              <a:t>• Inconsistent aggregation/disaggregation of line items across business units.</a:t>
+              <a:t>• Business units group similar costs differently; the new rule needs much more consistency here.</a:t>
             </a:r>
           </a:p>
           <a:p>
@@ -3833,7 +3833,7 @@
                 </a:solidFill>
                 <a:latin typeface="Calibri"/>
               </a:rPr>
-              <a:t>• No dedicated budget/resourcing yet assigned for IFRS 18 readiness.</a:t>
+              <a:t>• No dedicated time or budget yet assigned to prepare for this change.</a:t>
             </a:r>
           </a:p>
         </p:txBody>
@@ -3890,7 +3890,7 @@
                 </a:solidFill>
                 <a:latin typeface="Calibri"/>
               </a:rPr>
-              <a:t>• Achieve full IFRS 18 compliance before mandatory effective date (periods beginning ≥ 1 Jan 2027; comparatives from 1 Jan 2026).</a:t>
+              <a:t>• Be fully ready for IFRS 18 before it's mandatory (years starting on/after 1 Jan 2027; last year's figures restated from 1 Jan 2026).</a:t>
             </a:r>
           </a:p>
           <a:p>
@@ -3906,7 +3906,7 @@
                 </a:solidFill>
                 <a:latin typeface="Calibri"/>
               </a:rPr>
-              <a:t>• Gap assessment of chart of accounts, consolidation system and disclosure templates vs. the 3 new categories &amp; 2 new subtotals.</a:t>
+              <a:t>• Check what needs to change in our accounts, systems and templates for the 3 new groups &amp; 2 new required subtotals.</a:t>
             </a:r>
           </a:p>
           <a:p>
@@ -3922,7 +3922,7 @@
                 </a:solidFill>
                 <a:latin typeface="Calibri"/>
               </a:rPr>
-              <a:t>• Define &amp; govern Management-Defined Performance Measures (MPMs), incl. required reconciliation disclosures.</a:t>
+              <a:t>• Set clear, approved rules for our "adjusted" performance numbers, incl. showing how they connect back to the official numbers.</a:t>
             </a:r>
           </a:p>
           <a:p>
@@ -3938,7 +3938,7 @@
                 </a:solidFill>
                 <a:latin typeface="Calibri"/>
               </a:rPr>
-              <a:t>• Reconfigure P&amp;L structure, CoA mapping and consolidation tool for native category/subtotal reporting.</a:t>
+              <a:t>• Update our P&amp;L structure, account mapping and reporting system so the new groups/subtotals are produced automatically.</a:t>
             </a:r>
           </a:p>
           <a:p>
@@ -3954,7 +3954,7 @@
                 </a:solidFill>
                 <a:latin typeface="Calibri"/>
               </a:rPr>
-              <a:t>• Update statutory templates, disclosure checklists and cash-flow reconciliation logic; train Finance/Controlling/IR.</a:t>
+              <a:t>• Update official templates, checklists and cash-flow statement; train Finance/Controlling/Investor Relations.</a:t>
             </a:r>
           </a:p>
           <a:p>
@@ -3970,7 +3970,7 @@
                 </a:solidFill>
                 <a:latin typeface="Calibri"/>
               </a:rPr>
-              <a:t>• Run a parallel/dry-run cycle and align with external auditors on transition approach.</a:t>
+              <a:t>• Run a test/dry-run cycle and work with our external auditors on how we make the change.</a:t>
             </a:r>
           </a:p>
         </p:txBody>
@@ -4133,7 +4133,7 @@
                 </a:solidFill>
                 <a:latin typeface="Calibri"/>
               </a:rPr>
-              <a:t>• Full compliance with mandatory standard; avoids audit qualification.</a:t>
+              <a:t>• We follow the new mandatory rule, avoiding audit and regulatory risk.</a:t>
             </a:r>
           </a:p>
           <a:p>
@@ -4149,7 +4149,7 @@
                 </a:solidFill>
                 <a:latin typeface="Calibri"/>
               </a:rPr>
-              <a:t>• Improved comparability/transparency for investors via standardized subtotals.</a:t>
+              <a:t>• Our statements become easier to compare, for our teams and investors.</a:t>
             </a:r>
           </a:p>
           <a:p>
@@ -4165,7 +4165,7 @@
                 </a:solidFill>
                 <a:latin typeface="Calibri"/>
               </a:rPr>
-              <a:t>• Stronger governance/audit trail over non-GAAP measures.</a:t>
+              <a:t>• Clearer, better-documented rules for our adjusted performance numbers.</a:t>
             </a:r>
           </a:p>
           <a:p>
@@ -4181,7 +4181,7 @@
                 </a:solidFill>
                 <a:latin typeface="Calibri"/>
               </a:rPr>
-              <a:t>• Harmonized P&amp;L supports statutory &amp; management reporting.</a:t>
+              <a:t>• Simpler, more consistent P&amp;L for both official and internal reporting.</a:t>
             </a:r>
           </a:p>
           <a:p>
@@ -4197,7 +4197,7 @@
                 </a:solidFill>
                 <a:latin typeface="Calibri"/>
               </a:rPr>
-              <a:t>• Reduced manual effort/error risk at close.</a:t>
+              <a:t>• Less manual work and fewer mistakes at closing time.</a:t>
             </a:r>
           </a:p>
         </p:txBody>
@@ -4307,7 +4307,7 @@
                 </a:solidFill>
                 <a:latin typeface="Calibri"/>
               </a:rPr>
-              <a:t>• Reduced manual closing/adjustment effort per cycle once automated (FTE-days TBD after design phase).</a:t>
+              <a:t>• Less manual work each closing cycle once the system sorts things automatically (exact savings TBD after detailed review).</a:t>
             </a:r>
           </a:p>
           <a:p>
@@ -4323,7 +4323,7 @@
                 </a:solidFill>
                 <a:latin typeface="Calibri"/>
               </a:rPr>
-              <a:t>• Avoidance of one-off remediation costs (advisory, late changes, audit findings) from a rushed transition.</a:t>
+              <a:t>• We avoid extra costs (advisors, rushed fixes, audit findings) from leaving this until the last minute.</a:t>
             </a:r>
           </a:p>
           <a:p>
@@ -4339,7 +4339,7 @@
                 </a:solidFill>
                 <a:latin typeface="Calibri"/>
               </a:rPr>
-              <a:t>• Precise figures to be confirmed after gap assessment.</a:t>
+              <a:t>• Exact figures to be confirmed after the initial review.</a:t>
             </a:r>
           </a:p>
         </p:txBody>
@@ -4497,7 +4497,7 @@
                 </a:solidFill>
                 <a:latin typeface="Calibri"/>
               </a:rPr>
-              <a:t>• Consolidation &amp; Reporting Systems / IT</a:t>
+              <a:t>• IT / Reporting Systems team</a:t>
             </a:r>
           </a:p>
           <a:p>
@@ -4529,7 +4529,7 @@
                 </a:solidFill>
                 <a:latin typeface="Calibri"/>
               </a:rPr>
-              <a:t>• Business Unit Controllers</a:t>
+              <a:t>• Local Finance teams (Business Units)</a:t>
             </a:r>
           </a:p>
         </p:txBody>
@@ -4647,7 +4647,7 @@
                 </a:solidFill>
                 <a:latin typeface="Calibri"/>
               </a:rPr>
-              <a:t>~40 PD (illustrative; IT/consolidation system config, CoA mapping, reports)</a:t>
+              <a:t>~40 person-days (rough estimate; updating IT systems, accounts, reports)</a:t>
             </a:r>
           </a:p>
           <a:p>
@@ -4683,7 +4683,7 @@
                 </a:solidFill>
                 <a:latin typeface="Calibri"/>
               </a:rPr>
-              <a:t>~25 PD (illustrative; gap assessment, MPM governance, policy, training)</a:t>
+              <a:t>~25 person-days (rough estimate; reviewing changes, setting rules, training)</a:t>
             </a:r>
           </a:p>
         </p:txBody>

</xml_diff>